<commit_message>
fix: light boxes in slides (replaced 19 dark fills)
</commit_message>
<xml_diff>
--- a/slides.pptx
+++ b/slides.pptx
@@ -3337,7 +3337,7 @@
             <a:avLst/>
           </a:prstGeom>
           <a:solidFill>
-            <a:srgbClr val="22223A"/>
+            <a:srgbClr val="F0F4F8"/>
           </a:solidFill>
           <a:ln w="19050">
             <a:solidFill>
@@ -3660,7 +3660,7 @@
             <a:avLst/>
           </a:prstGeom>
           <a:solidFill>
-            <a:srgbClr val="22223A"/>
+            <a:srgbClr val="F0F4F8"/>
           </a:solidFill>
           <a:ln w="19050">
             <a:solidFill>
@@ -5424,7 +5424,7 @@
             <a:avLst/>
           </a:prstGeom>
           <a:solidFill>
-            <a:srgbClr val="22223A"/>
+            <a:srgbClr val="F0F4F8"/>
           </a:solidFill>
           <a:ln w="19050">
             <a:solidFill>
@@ -5557,7 +5557,7 @@
             <a:avLst/>
           </a:prstGeom>
           <a:solidFill>
-            <a:srgbClr val="22223A"/>
+            <a:srgbClr val="F0F4F8"/>
           </a:solidFill>
           <a:ln w="19050">
             <a:solidFill>
@@ -5880,7 +5880,7 @@
             <a:avLst/>
           </a:prstGeom>
           <a:solidFill>
-            <a:srgbClr val="22223A"/>
+            <a:srgbClr val="F0F4F8"/>
           </a:solidFill>
           <a:ln w="25400">
             <a:solidFill>
@@ -6172,7 +6172,7 @@
             <a:avLst/>
           </a:prstGeom>
           <a:solidFill>
-            <a:srgbClr val="22223A"/>
+            <a:srgbClr val="F0F4F8"/>
           </a:solidFill>
           <a:ln w="19050">
             <a:solidFill>
@@ -6457,7 +6457,7 @@
             <a:avLst/>
           </a:prstGeom>
           <a:solidFill>
-            <a:srgbClr val="22223A"/>
+            <a:srgbClr val="F0F4F8"/>
           </a:solidFill>
           <a:ln w="19050">
             <a:solidFill>
@@ -6551,7 +6551,7 @@
             <a:avLst/>
           </a:prstGeom>
           <a:solidFill>
-            <a:srgbClr val="22223A"/>
+            <a:srgbClr val="F0F4F8"/>
           </a:solidFill>
           <a:ln w="19050">
             <a:solidFill>
@@ -6645,7 +6645,7 @@
             <a:avLst/>
           </a:prstGeom>
           <a:solidFill>
-            <a:srgbClr val="22223A"/>
+            <a:srgbClr val="F0F4F8"/>
           </a:solidFill>
           <a:ln w="19050">
             <a:solidFill>
@@ -6739,7 +6739,7 @@
             <a:avLst/>
           </a:prstGeom>
           <a:solidFill>
-            <a:srgbClr val="22223A"/>
+            <a:srgbClr val="F0F4F8"/>
           </a:solidFill>
           <a:ln w="19050">
             <a:solidFill>
@@ -7373,7 +7373,7 @@
             <a:avLst/>
           </a:prstGeom>
           <a:solidFill>
-            <a:srgbClr val="22223A"/>
+            <a:srgbClr val="F0F4F8"/>
           </a:solidFill>
           <a:ln w="19050">
             <a:solidFill>
@@ -7614,7 +7614,7 @@
             <a:avLst/>
           </a:prstGeom>
           <a:solidFill>
-            <a:srgbClr val="22223A"/>
+            <a:srgbClr val="F0F4F8"/>
           </a:solidFill>
           <a:ln w="19050">
             <a:solidFill>
@@ -7957,7 +7957,7 @@
             <a:avLst/>
           </a:prstGeom>
           <a:solidFill>
-            <a:srgbClr val="22223A"/>
+            <a:srgbClr val="F0F4F8"/>
           </a:solidFill>
           <a:ln w="25400">
             <a:solidFill>
@@ -8210,7 +8210,7 @@
             <a:avLst/>
           </a:prstGeom>
           <a:solidFill>
-            <a:srgbClr val="22223A"/>
+            <a:srgbClr val="F0F4F8"/>
           </a:solidFill>
           <a:ln w="19050">
             <a:solidFill>
@@ -8426,7 +8426,7 @@
             <a:avLst/>
           </a:prstGeom>
           <a:solidFill>
-            <a:srgbClr val="22223A"/>
+            <a:srgbClr val="F0F4F8"/>
           </a:solidFill>
           <a:ln w="19050">
             <a:solidFill>
@@ -8642,7 +8642,7 @@
             <a:avLst/>
           </a:prstGeom>
           <a:solidFill>
-            <a:srgbClr val="22223A"/>
+            <a:srgbClr val="F0F4F8"/>
           </a:solidFill>
           <a:ln w="19050">
             <a:solidFill>
@@ -9064,7 +9064,7 @@
             <a:avLst/>
           </a:prstGeom>
           <a:solidFill>
-            <a:srgbClr val="22223A"/>
+            <a:srgbClr val="F0F4F8"/>
           </a:solidFill>
           <a:ln w="19050">
             <a:solidFill>
@@ -11626,7 +11626,7 @@
             <a:avLst/>
           </a:prstGeom>
           <a:solidFill>
-            <a:srgbClr val="22223A"/>
+            <a:srgbClr val="F0F4F8"/>
           </a:solidFill>
           <a:ln w="19050">
             <a:solidFill>
@@ -11724,7 +11724,7 @@
             <a:avLst/>
           </a:prstGeom>
           <a:solidFill>
-            <a:srgbClr val="22223A"/>
+            <a:srgbClr val="F0F4F8"/>
           </a:solidFill>
           <a:ln w="19050">
             <a:solidFill>
@@ -11818,7 +11818,7 @@
             <a:avLst/>
           </a:prstGeom>
           <a:solidFill>
-            <a:srgbClr val="22223A"/>
+            <a:srgbClr val="F0F4F8"/>
           </a:solidFill>
           <a:ln w="19050">
             <a:solidFill>
@@ -11916,7 +11916,7 @@
             <a:avLst/>
           </a:prstGeom>
           <a:solidFill>
-            <a:srgbClr val="22223A"/>
+            <a:srgbClr val="F0F4F8"/>
           </a:solidFill>
           <a:ln w="19050">
             <a:solidFill>
@@ -12317,7 +12317,7 @@
             <a:avLst/>
           </a:prstGeom>
           <a:solidFill>
-            <a:srgbClr val="22223A"/>
+            <a:srgbClr val="F0F4F8"/>
           </a:solidFill>
           <a:ln w="19050">
             <a:solidFill>
@@ -12641,7 +12641,7 @@
             <a:avLst/>
           </a:prstGeom>
           <a:solidFill>
-            <a:srgbClr val="22223A"/>
+            <a:srgbClr val="F0F4F8"/>
           </a:solidFill>
           <a:ln w="19050">
             <a:solidFill>
@@ -12946,7 +12946,7 @@
             <a:avLst/>
           </a:prstGeom>
           <a:solidFill>
-            <a:srgbClr val="22223A"/>
+            <a:srgbClr val="F0F4F8"/>
           </a:solidFill>
           <a:ln w="19050">
             <a:solidFill>
@@ -13040,7 +13040,7 @@
             <a:avLst/>
           </a:prstGeom>
           <a:solidFill>
-            <a:srgbClr val="22223A"/>
+            <a:srgbClr val="F0F4F8"/>
           </a:solidFill>
           <a:ln w="19050">
             <a:solidFill>
@@ -13134,7 +13134,7 @@
             <a:avLst/>
           </a:prstGeom>
           <a:solidFill>
-            <a:srgbClr val="22223A"/>
+            <a:srgbClr val="F0F4F8"/>
           </a:solidFill>
           <a:ln w="19050">
             <a:solidFill>

</xml_diff>